<commit_message>
Minor changes to several documents
Changes made during Autumn 2025
</commit_message>
<xml_diff>
--- a/Chap/Misc/GitHubEssentialsSimplified.pptx
+++ b/Chap/Misc/GitHubEssentialsSimplified.pptx
@@ -320,7 +320,7 @@
           <a:p>
             <a:fld id="{6D3C1FF0-A856-4E7A-B4DD-9DB70D4CF906}" type="datetimeFigureOut">
               <a:rPr lang="da-DK" smtClean="0"/>
-              <a:t>05-08-2025</a:t>
+              <a:t>30-11-2025</a:t>
             </a:fld>
             <a:endParaRPr lang="da-DK"/>
           </a:p>
@@ -530,7 +530,7 @@
           <a:p>
             <a:fld id="{6D3C1FF0-A856-4E7A-B4DD-9DB70D4CF906}" type="datetimeFigureOut">
               <a:rPr lang="da-DK" smtClean="0"/>
-              <a:t>05-08-2025</a:t>
+              <a:t>30-11-2025</a:t>
             </a:fld>
             <a:endParaRPr lang="da-DK"/>
           </a:p>
@@ -750,7 +750,7 @@
           <a:p>
             <a:fld id="{6D3C1FF0-A856-4E7A-B4DD-9DB70D4CF906}" type="datetimeFigureOut">
               <a:rPr lang="da-DK" smtClean="0"/>
-              <a:t>05-08-2025</a:t>
+              <a:t>30-11-2025</a:t>
             </a:fld>
             <a:endParaRPr lang="da-DK"/>
           </a:p>
@@ -960,7 +960,7 @@
           <a:p>
             <a:fld id="{6D3C1FF0-A856-4E7A-B4DD-9DB70D4CF906}" type="datetimeFigureOut">
               <a:rPr lang="da-DK" smtClean="0"/>
-              <a:t>05-08-2025</a:t>
+              <a:t>30-11-2025</a:t>
             </a:fld>
             <a:endParaRPr lang="da-DK"/>
           </a:p>
@@ -1247,7 +1247,7 @@
           <a:p>
             <a:fld id="{6D3C1FF0-A856-4E7A-B4DD-9DB70D4CF906}" type="datetimeFigureOut">
               <a:rPr lang="da-DK" smtClean="0"/>
-              <a:t>05-08-2025</a:t>
+              <a:t>30-11-2025</a:t>
             </a:fld>
             <a:endParaRPr lang="da-DK"/>
           </a:p>
@@ -1524,7 +1524,7 @@
           <a:p>
             <a:fld id="{6D3C1FF0-A856-4E7A-B4DD-9DB70D4CF906}" type="datetimeFigureOut">
               <a:rPr lang="da-DK" smtClean="0"/>
-              <a:t>05-08-2025</a:t>
+              <a:t>30-11-2025</a:t>
             </a:fld>
             <a:endParaRPr lang="da-DK"/>
           </a:p>
@@ -1948,7 +1948,7 @@
           <a:p>
             <a:fld id="{6D3C1FF0-A856-4E7A-B4DD-9DB70D4CF906}" type="datetimeFigureOut">
               <a:rPr lang="da-DK" smtClean="0"/>
-              <a:t>05-08-2025</a:t>
+              <a:t>30-11-2025</a:t>
             </a:fld>
             <a:endParaRPr lang="da-DK"/>
           </a:p>
@@ -2101,7 +2101,7 @@
           <a:p>
             <a:fld id="{6D3C1FF0-A856-4E7A-B4DD-9DB70D4CF906}" type="datetimeFigureOut">
               <a:rPr lang="da-DK" smtClean="0"/>
-              <a:t>05-08-2025</a:t>
+              <a:t>30-11-2025</a:t>
             </a:fld>
             <a:endParaRPr lang="da-DK"/>
           </a:p>
@@ -2226,7 +2226,7 @@
           <a:p>
             <a:fld id="{6D3C1FF0-A856-4E7A-B4DD-9DB70D4CF906}" type="datetimeFigureOut">
               <a:rPr lang="da-DK" smtClean="0"/>
-              <a:t>05-08-2025</a:t>
+              <a:t>30-11-2025</a:t>
             </a:fld>
             <a:endParaRPr lang="da-DK"/>
           </a:p>
@@ -2549,7 +2549,7 @@
           <a:p>
             <a:fld id="{6D3C1FF0-A856-4E7A-B4DD-9DB70D4CF906}" type="datetimeFigureOut">
               <a:rPr lang="da-DK" smtClean="0"/>
-              <a:t>05-08-2025</a:t>
+              <a:t>30-11-2025</a:t>
             </a:fld>
             <a:endParaRPr lang="da-DK"/>
           </a:p>
@@ -2849,7 +2849,7 @@
           <a:p>
             <a:fld id="{6D3C1FF0-A856-4E7A-B4DD-9DB70D4CF906}" type="datetimeFigureOut">
               <a:rPr lang="da-DK" smtClean="0"/>
-              <a:t>05-08-2025</a:t>
+              <a:t>30-11-2025</a:t>
             </a:fld>
             <a:endParaRPr lang="da-DK"/>
           </a:p>
@@ -3102,7 +3102,7 @@
           <a:p>
             <a:fld id="{6D3C1FF0-A856-4E7A-B4DD-9DB70D4CF906}" type="datetimeFigureOut">
               <a:rPr lang="da-DK" smtClean="0"/>
-              <a:t>05-08-2025</a:t>
+              <a:t>30-11-2025</a:t>
             </a:fld>
             <a:endParaRPr lang="da-DK"/>
           </a:p>
@@ -6981,6 +6981,60 @@
           </a:p>
         </p:txBody>
       </p:sp>
+      <p:sp>
+        <p:nvSpPr>
+          <p:cNvPr id="16" name="Rektangel 15">
+            <a:extLst>
+              <a:ext uri="{FF2B5EF4-FFF2-40B4-BE49-F238E27FC236}">
+                <a16:creationId xmlns:a16="http://schemas.microsoft.com/office/drawing/2014/main" id="{5DD7A457-A05C-4119-918B-333DFD8E1F46}"/>
+              </a:ext>
+            </a:extLst>
+          </p:cNvPr>
+          <p:cNvSpPr/>
+          <p:nvPr/>
+        </p:nvSpPr>
+        <p:spPr>
+          <a:xfrm>
+            <a:off x="2870719" y="5335944"/>
+            <a:ext cx="815788" cy="486183"/>
+          </a:xfrm>
+          <a:prstGeom prst="rect">
+            <a:avLst/>
+          </a:prstGeom>
+          <a:solidFill>
+            <a:schemeClr val="bg1">
+              <a:lumMod val="50000"/>
+            </a:schemeClr>
+          </a:solidFill>
+        </p:spPr>
+        <p:style>
+          <a:lnRef idx="2">
+            <a:schemeClr val="accent1">
+              <a:shade val="50000"/>
+            </a:schemeClr>
+          </a:lnRef>
+          <a:fillRef idx="1">
+            <a:schemeClr val="accent1"/>
+          </a:fillRef>
+          <a:effectRef idx="0">
+            <a:schemeClr val="accent1"/>
+          </a:effectRef>
+          <a:fontRef idx="minor">
+            <a:schemeClr val="lt1"/>
+          </a:fontRef>
+        </p:style>
+        <p:txBody>
+          <a:bodyPr rtlCol="0" anchor="t"/>
+          <a:lstStyle/>
+          <a:p>
+            <a:r>
+              <a:rPr lang="en-US" b="1"/>
+              <a:t>Save</a:t>
+            </a:r>
+            <a:endParaRPr lang="da-DK" b="1" dirty="0"/>
+          </a:p>
+        </p:txBody>
+      </p:sp>
     </p:spTree>
     <p:extLst>
       <p:ext uri="{BB962C8B-B14F-4D97-AF65-F5344CB8AC3E}">
@@ -8709,8 +8763,12 @@
           </a:p>
           <a:p>
             <a:r>
+              <a:rPr lang="da-DK" u="sng" dirty="0"/>
+              <a:t>Talk</a:t>
+            </a:r>
+            <a:r>
               <a:rPr lang="da-DK" dirty="0"/>
-              <a:t>Talk to </a:t>
+              <a:t> to </a:t>
             </a:r>
             <a:r>
               <a:rPr lang="da-DK" dirty="0" err="1"/>
@@ -8731,7 +8789,7 @@
           </a:p>
           <a:p>
             <a:r>
-              <a:rPr lang="da-DK" dirty="0" err="1"/>
+              <a:rPr lang="da-DK" u="sng" dirty="0" err="1"/>
               <a:t>Inform</a:t>
             </a:r>
             <a:r>
@@ -8771,26 +8829,39 @@
               <a:t> </a:t>
             </a:r>
             <a:r>
-              <a:rPr lang="da-DK" dirty="0" err="1"/>
+              <a:rPr lang="da-DK" err="1"/>
               <a:t>are</a:t>
             </a:r>
             <a:r>
+              <a:rPr lang="da-DK"/>
+              <a:t> made!</a:t>
+            </a:r>
+            <a:endParaRPr lang="da-DK" dirty="0"/>
+          </a:p>
+          <a:p>
+            <a:r>
               <a:rPr lang="da-DK" dirty="0"/>
-              <a:t> made.</a:t>
-            </a:r>
-          </a:p>
-          <a:p>
+              <a:t>Do </a:t>
+            </a:r>
+            <a:r>
+              <a:rPr lang="da-DK" u="sng" dirty="0"/>
+              <a:t>not</a:t>
+            </a:r>
             <a:r>
               <a:rPr lang="da-DK" dirty="0"/>
-              <a:t>Do not </a:t>
-            </a:r>
-            <a:r>
-              <a:rPr lang="da-DK" dirty="0" err="1"/>
+              <a:t> </a:t>
+            </a:r>
+            <a:r>
+              <a:rPr lang="da-DK" err="1"/>
               <a:t>build</a:t>
             </a:r>
             <a:r>
+              <a:rPr lang="da-DK"/>
+              <a:t> up </a:t>
+            </a:r>
+            <a:r>
               <a:rPr lang="da-DK" dirty="0"/>
-              <a:t> up ”</a:t>
+              <a:t>”</a:t>
             </a:r>
             <a:r>
               <a:rPr lang="da-DK" dirty="0" err="1"/>
@@ -8809,16 +8880,12 @@
               <a:t>/</a:t>
             </a:r>
             <a:r>
-              <a:rPr lang="da-DK" dirty="0" err="1"/>
+              <a:rPr lang="da-DK" err="1"/>
               <a:t>unpulled</a:t>
             </a:r>
             <a:r>
-              <a:rPr lang="da-DK" dirty="0"/>
-              <a:t> </a:t>
-            </a:r>
-            <a:r>
-              <a:rPr lang="da-DK" dirty="0" err="1"/>
-              <a:t>changes</a:t>
+              <a:rPr lang="da-DK"/>
+              <a:t> changes!</a:t>
             </a:r>
             <a:endParaRPr lang="da-DK" dirty="0"/>
           </a:p>
@@ -9259,8 +9326,20 @@
           </a:p>
           <a:p>
             <a:r>
+              <a:rPr lang="en-US" sz="2600"/>
+              <a:t>GitHub does </a:t>
+            </a:r>
+            <a:r>
+              <a:rPr lang="en-US" sz="2600" u="sng"/>
+              <a:t>not</a:t>
+            </a:r>
+            <a:r>
+              <a:rPr lang="en-US" sz="2600"/>
+              <a:t> </a:t>
+            </a:r>
+            <a:r>
               <a:rPr lang="en-US" sz="2600" dirty="0"/>
-              <a:t>GitHub doesn’t replace communication and common sense…</a:t>
+              <a:t>replace communication and common sense…</a:t>
             </a:r>
             <a:endParaRPr lang="da-DK" sz="2600" dirty="0"/>
           </a:p>
@@ -11698,6 +11777,60 @@
                 <a:srgbClr val="FFFF00"/>
               </a:solidFill>
             </a:endParaRPr>
+          </a:p>
+        </p:txBody>
+      </p:sp>
+      <p:sp>
+        <p:nvSpPr>
+          <p:cNvPr id="16" name="Rektangel 15">
+            <a:extLst>
+              <a:ext uri="{FF2B5EF4-FFF2-40B4-BE49-F238E27FC236}">
+                <a16:creationId xmlns:a16="http://schemas.microsoft.com/office/drawing/2014/main" id="{CBC511F7-2EE5-4D27-AADE-2CD1FBC02CEE}"/>
+              </a:ext>
+            </a:extLst>
+          </p:cNvPr>
+          <p:cNvSpPr/>
+          <p:nvPr/>
+        </p:nvSpPr>
+        <p:spPr>
+          <a:xfrm>
+            <a:off x="2870719" y="5335944"/>
+            <a:ext cx="815788" cy="486183"/>
+          </a:xfrm>
+          <a:prstGeom prst="rect">
+            <a:avLst/>
+          </a:prstGeom>
+          <a:solidFill>
+            <a:schemeClr val="bg1">
+              <a:lumMod val="50000"/>
+            </a:schemeClr>
+          </a:solidFill>
+        </p:spPr>
+        <p:style>
+          <a:lnRef idx="2">
+            <a:schemeClr val="accent1">
+              <a:shade val="50000"/>
+            </a:schemeClr>
+          </a:lnRef>
+          <a:fillRef idx="1">
+            <a:schemeClr val="accent1"/>
+          </a:fillRef>
+          <a:effectRef idx="0">
+            <a:schemeClr val="accent1"/>
+          </a:effectRef>
+          <a:fontRef idx="minor">
+            <a:schemeClr val="lt1"/>
+          </a:fontRef>
+        </p:style>
+        <p:txBody>
+          <a:bodyPr rtlCol="0" anchor="t"/>
+          <a:lstStyle/>
+          <a:p>
+            <a:r>
+              <a:rPr lang="en-US" b="1"/>
+              <a:t>Save</a:t>
+            </a:r>
+            <a:endParaRPr lang="da-DK" b="1" dirty="0"/>
           </a:p>
         </p:txBody>
       </p:sp>

</xml_diff>